<commit_message>
Replace final application slide with Thank you
</commit_message>
<xml_diff>
--- a/docs/presentation/OpenArt-What-We-Made-Simplified-v18.pptx
+++ b/docs/presentation/OpenArt-What-We-Made-Simplified-v18.pptx
@@ -626,37 +626,7 @@
           <a:lstStyle xmlns:a="http://schemas.openxmlformats.org/drawingml/2006/main"/>
           <a:p xmlns:a="http://schemas.openxmlformats.org/drawingml/2006/main">
             <a:r>
-              <a:t>Four independent reviews covered security, TypeScript, database behavior and machine learning/statistics. About 60 findings included a production-breaking Firestore issue under Node 22 fetch, malformed-URL crashes, profit scoring at the wrong moment, a stop-loss that fired on most null arms, and warehouse coverage missing 18 of 29 injected bugs. All findings were fixed with regression tests and the sealed proof reran on final code.</a:t>
-            </a:r>
-          </a:p>
-          <a:p xmlns:a="http://schemas.openxmlformats.org/drawingml/2006/main">
-            <a:r>
-              <a:t>The repository reports 1,484 TypeScript tests and 505 dbt checks passing. Warehouse validation separately lists 41 TypeScript tests and 66 Python tests. We preserve the reported repository total and list the separate warehouse validation on its slide.</a:t>
-            </a:r>
-          </a:p>
-          <a:p xmlns:a="http://schemas.openxmlformats.org/drawingml/2006/main">
-            <a:r>
-              <a:t>Delivery comprises eight packages, integration documentation, proof artifacts and scheduling configuration. It does not include a production deployment. Platform senders remain dry-run by default, and audience sync remains dry-run only. Nothing in this repository has sent data to OpenArt systems or advertising platforms.</a:t>
-            </a:r>
-          </a:p>
-          <a:p xmlns:a="http://schemas.openxmlformats.org/drawingml/2006/main">
-            <a:r>
-              <a:t>Verified behavior comes from the live site and shipped code. Profit coefficients, cohort parameters, simulation results and public-list-price generation costs remain illustrative. OpenArt must supply real costs and data, confirm backend/warehouse integrations, platform access and LaunchDarkly context details, validate EU consent behavior and choose the LinkedIn purchase approach.</a:t>
-            </a:r>
-          </a:p>
-          <a:p xmlns:a="http://schemas.openxmlformats.org/drawingml/2006/main">
-            <a:r>
               <a:t/>
-            </a:r>
-          </a:p>
-          <a:p xmlns:a="http://schemas.openxmlformats.org/drawingml/2006/main">
-            <a:r>
-              <a:t>Sources: User-supplied detailed brief in this conversation. Repository change record: https://github.com/soup2964-spec/open-art-harness/blob/cb523467a82c65b6525062cc51c36f4311a99c2b/docs/CHANGES.md</a:t>
-            </a:r>
-          </a:p>
-          <a:p xmlns:a="http://schemas.openxmlformats.org/drawingml/2006/main">
-            <a:r>
-              <a:t>Style reference and original logo: https://openart.ai/ and https://openart.ai/suite/home. OpenArt font CSS: /suite/_next/static/chunks/287a8e175464349f.css. Font files: Google Fonts official Bricolage Grotesque, Inter and Geist Mono repositories.</a:t>
             </a:r>
           </a:p>
         </p:txBody>
@@ -6441,226 +6411,6 @@
       <p:grpSpPr>
         <a:xfrm xmlns:a="http://schemas.openxmlformats.org/drawingml/2006/main"/>
       </p:grpSpPr>
-      <p:pic>
-        <p:nvPicPr>
-          <p:cNvPr id="38" name="">
-            <a:extLst xmlns:a="http://schemas.openxmlformats.org/drawingml/2006/main">
-              <a:ext uri="{FF2B5EF4-FFF2-40B4-BE49-F238E27FC236}">
-                <a16:creationId xmlns:a16="http://schemas.microsoft.com/office/drawing/2014/main" id="{7BB4BF48-23EA-4095-B4C9-355DF8F244A7}"/>
-              </a:ext>
-            </a:extLst>
-          </p:cNvPr>
-          <p:cNvPicPr>
-            <a:picLocks xmlns:a="http://schemas.openxmlformats.org/drawingml/2006/main" noChangeAspect="1"/>
-          </p:cNvPicPr>
-          <p:nvPr/>
-        </p:nvPicPr>
-        <p:blipFill>
-          <a:blip xmlns:r="http://schemas.openxmlformats.org/officeDocument/2006/relationships" xmlns:a="http://schemas.openxmlformats.org/drawingml/2006/main" r:embed="R3f834b4e7bf44dbe">
-            <a:extLst>
-              <a:ext uri="{96DAC541-7B7A-43D3-8B79-37D633B846F1}">
-                <asvg:svgBlip xmlns:asvg="http://schemas.microsoft.com/office/drawing/2016/SVG/main" r:embed="Rfc69cc043dfe497a"/>
-              </a:ext>
-            </a:extLst>
-          </a:blip>
-          <a:stretch xmlns:a="http://schemas.openxmlformats.org/drawingml/2006/main"/>
-        </p:blipFill>
-        <p:spPr>
-          <a:xfrm xmlns:a="http://schemas.openxmlformats.org/drawingml/2006/main">
-            <a:off x="666750" y="428625"/>
-            <a:ext cx="2152650" cy="361950"/>
-          </a:xfrm>
-          <a:prstGeom xmlns:a="http://schemas.openxmlformats.org/drawingml/2006/main" prst="rect">
-            <a:avLst/>
-          </a:prstGeom>
-        </p:spPr>
-      </p:pic>
-      <p:sp>
-        <p:nvSpPr>
-          <p:cNvPr id="2" name="text-168">
-            <a:extLst xmlns:a="http://schemas.openxmlformats.org/drawingml/2006/main">
-              <a:ext uri="{FF2B5EF4-FFF2-40B4-BE49-F238E27FC236}">
-                <a16:creationId xmlns:a16="http://schemas.microsoft.com/office/drawing/2014/main" id="{B3C2DC68-F071-40A7-B1B0-4BE9C4D03EE2}"/>
-              </a:ext>
-            </a:extLst>
-          </p:cNvPr>
-          <p:cNvSpPr>
-            <a:spLocks xmlns:a="http://schemas.openxmlformats.org/drawingml/2006/main" noGrp="1"/>
-          </p:cNvSpPr>
-          <p:nvPr/>
-        </p:nvSpPr>
-        <p:spPr>
-          <a:xfrm xmlns:a="http://schemas.openxmlformats.org/drawingml/2006/main">
-            <a:off x="3095625" y="428625"/>
-            <a:ext cx="5810250" cy="400050"/>
-          </a:xfrm>
-          <a:prstGeom xmlns:a="http://schemas.openxmlformats.org/drawingml/2006/main" prst="rect">
-            <a:avLst/>
-          </a:prstGeom>
-          <a:noFill xmlns:a="http://schemas.openxmlformats.org/drawingml/2006/main"/>
-          <a:ln xmlns:a="http://schemas.openxmlformats.org/drawingml/2006/main" w="0">
-            <a:noFill/>
-          </a:ln>
-        </p:spPr>
-        <p:txBody>
-          <a:bodyPr xmlns:a="http://schemas.openxmlformats.org/drawingml/2006/main" wrap="square" lIns="0" tIns="0" rIns="0" bIns="0" anchor="t">
-            <a:noAutofit/>
-          </a:bodyPr>
-          <a:lstStyle xmlns:a="http://schemas.openxmlformats.org/drawingml/2006/main"/>
-          <a:p xmlns:a="http://schemas.openxmlformats.org/drawingml/2006/main">
-            <a:pPr algn="l">
-              <a:buNone/>
-              <a:defRPr sz="1950" b="0">
-                <a:solidFill>
-                  <a:srgbClr val="AAA7AF"/>
-                </a:solidFill>
-                <a:latin typeface="Inter"/>
-                <a:ea typeface="Inter"/>
-                <a:cs typeface="Inter"/>
-              </a:defRPr>
-            </a:pPr>
-            <a:r>
-              <a:rPr sz="1950" b="0">
-                <a:solidFill>
-                  <a:srgbClr val="AAA7AF"/>
-                </a:solidFill>
-                <a:latin typeface="Inter"/>
-                <a:ea typeface="Inter"/>
-                <a:cs typeface="Inter"/>
-              </a:rPr>
-              <a:t>What we made</a:t>
-            </a:r>
-          </a:p>
-        </p:txBody>
-      </p:sp>
-      <p:sp>
-        <p:nvSpPr>
-          <p:cNvPr id="3" name="">
-            <a:extLst xmlns:a="http://schemas.openxmlformats.org/drawingml/2006/main">
-              <a:ext uri="{FF2B5EF4-FFF2-40B4-BE49-F238E27FC236}">
-                <a16:creationId xmlns:a16="http://schemas.microsoft.com/office/drawing/2014/main" id="{17B47CE8-D7BF-45EE-A5C9-74FAF44C8022}"/>
-              </a:ext>
-            </a:extLst>
-          </p:cNvPr>
-          <p:cNvSpPr>
-            <a:spLocks xmlns:a="http://schemas.openxmlformats.org/drawingml/2006/main" noGrp="1"/>
-          </p:cNvSpPr>
-          <p:nvPr/>
-        </p:nvSpPr>
-        <p:spPr>
-          <a:xfrm xmlns:a="http://schemas.openxmlformats.org/drawingml/2006/main">
-            <a:off x="16363950" y="381000"/>
-            <a:ext cx="1257300" cy="457200"/>
-          </a:xfrm>
-          <a:prstGeom xmlns:a="http://schemas.openxmlformats.org/drawingml/2006/main" prst="roundRect">
-            <a:avLst>
-              <a:gd name="adj" fmla="val 50000"/>
-            </a:avLst>
-          </a:prstGeom>
-          <a:gradFill xmlns:a="http://schemas.openxmlformats.org/drawingml/2006/main">
-            <a:gsLst>
-              <a:gs pos="0">
-                <a:srgbClr val="FFB8E9"/>
-              </a:gs>
-              <a:gs pos="100000">
-                <a:srgbClr val="FF00BC"/>
-              </a:gs>
-            </a:gsLst>
-            <a:lin ang="0"/>
-          </a:gradFill>
-          <a:ln xmlns:a="http://schemas.openxmlformats.org/drawingml/2006/main" w="0">
-            <a:noFill/>
-          </a:ln>
-        </p:spPr>
-      </p:sp>
-      <p:sp>
-        <p:nvSpPr>
-          <p:cNvPr id="4" name="text-169">
-            <a:extLst xmlns:a="http://schemas.openxmlformats.org/drawingml/2006/main">
-              <a:ext uri="{FF2B5EF4-FFF2-40B4-BE49-F238E27FC236}">
-                <a16:creationId xmlns:a16="http://schemas.microsoft.com/office/drawing/2014/main" id="{6270FECD-61F9-4D63-A02C-1D942A9C5F84}"/>
-              </a:ext>
-            </a:extLst>
-          </p:cNvPr>
-          <p:cNvSpPr>
-            <a:spLocks xmlns:a="http://schemas.openxmlformats.org/drawingml/2006/main" noGrp="1"/>
-          </p:cNvSpPr>
-          <p:nvPr/>
-        </p:nvSpPr>
-        <p:spPr>
-          <a:xfrm xmlns:a="http://schemas.openxmlformats.org/drawingml/2006/main">
-            <a:off x="16535400" y="457200"/>
-            <a:ext cx="914400" cy="323850"/>
-          </a:xfrm>
-          <a:prstGeom xmlns:a="http://schemas.openxmlformats.org/drawingml/2006/main" prst="rect">
-            <a:avLst/>
-          </a:prstGeom>
-          <a:noFill xmlns:a="http://schemas.openxmlformats.org/drawingml/2006/main"/>
-          <a:ln xmlns:a="http://schemas.openxmlformats.org/drawingml/2006/main" w="0">
-            <a:noFill/>
-          </a:ln>
-        </p:spPr>
-        <p:txBody>
-          <a:bodyPr xmlns:a="http://schemas.openxmlformats.org/drawingml/2006/main" wrap="square" lIns="0" tIns="0" rIns="0" bIns="0" anchor="t">
-            <a:noAutofit/>
-          </a:bodyPr>
-          <a:lstStyle xmlns:a="http://schemas.openxmlformats.org/drawingml/2006/main"/>
-          <a:p xmlns:a="http://schemas.openxmlformats.org/drawingml/2006/main">
-            <a:pPr algn="ctr">
-              <a:buNone/>
-              <a:defRPr sz="1800" b="1">
-                <a:solidFill>
-                  <a:srgbClr val="EBEBEB"/>
-                </a:solidFill>
-                <a:latin typeface="Inter"/>
-                <a:ea typeface="Inter"/>
-                <a:cs typeface="Inter"/>
-              </a:defRPr>
-            </a:pPr>
-            <a:r>
-              <a:rPr sz="1800" b="1">
-                <a:solidFill>
-                  <a:srgbClr val="EBEBEB"/>
-                </a:solidFill>
-                <a:latin typeface="Inter"/>
-                <a:ea typeface="Inter"/>
-                <a:cs typeface="Inter"/>
-              </a:rPr>
-              <a:t>10 / 10</a:t>
-            </a:r>
-          </a:p>
-        </p:txBody>
-      </p:sp>
-      <p:sp>
-        <p:nvSpPr>
-          <p:cNvPr id="5" name="">
-            <a:extLst xmlns:a="http://schemas.openxmlformats.org/drawingml/2006/main">
-              <a:ext uri="{FF2B5EF4-FFF2-40B4-BE49-F238E27FC236}">
-                <a16:creationId xmlns:a16="http://schemas.microsoft.com/office/drawing/2014/main" id="{DD7A1482-21E5-4176-905B-6C7B3FAFA442}"/>
-              </a:ext>
-            </a:extLst>
-          </p:cNvPr>
-          <p:cNvSpPr>
-            <a:spLocks xmlns:a="http://schemas.openxmlformats.org/drawingml/2006/main" noGrp="1"/>
-          </p:cNvSpPr>
-          <p:nvPr/>
-        </p:nvSpPr>
-        <p:spPr>
-          <a:xfrm xmlns:a="http://schemas.openxmlformats.org/drawingml/2006/main">
-            <a:off x="666750" y="1000125"/>
-            <a:ext cx="16954500" cy="0"/>
-          </a:xfrm>
-          <a:prstGeom xmlns:a="http://schemas.openxmlformats.org/drawingml/2006/main" prst="line">
-            <a:avLst/>
-          </a:prstGeom>
-          <a:noFill xmlns:a="http://schemas.openxmlformats.org/drawingml/2006/main"/>
-          <a:ln xmlns:a="http://schemas.openxmlformats.org/drawingml/2006/main" w="9525">
-            <a:solidFill>
-              <a:srgbClr val="29262D"/>
-            </a:solidFill>
-          </a:ln>
-        </p:spPr>
-      </p:sp>
       <p:sp>
         <p:nvSpPr>
           <p:cNvPr id="6" name="text-170">
@@ -6677,8 +6427,8 @@
         </p:nvSpPr>
         <p:spPr>
           <a:xfrm xmlns:a="http://schemas.openxmlformats.org/drawingml/2006/main">
-            <a:off x="666750" y="1323975"/>
-            <a:ext cx="13811250" cy="990600"/>
+            <a:off x="1524000" y="4000500"/>
+            <a:ext cx="15240000" cy="2286000"/>
           </a:xfrm>
           <a:prstGeom xmlns:a="http://schemas.openxmlformats.org/drawingml/2006/main" prst="rect">
             <a:avLst/>
@@ -6689,16 +6439,35 @@
           </a:ln>
         </p:spPr>
         <p:txBody>
-          <a:bodyPr xmlns:a="http://schemas.openxmlformats.org/drawingml/2006/main" wrap="square" lIns="0" tIns="0" rIns="0" bIns="0" anchor="t">
+          <a:bodyPr xmlns:a="http://schemas.openxmlformats.org/drawingml/2006/main" wrap="none" lIns="0" tIns="0" rIns="0" bIns="0" anchor="ctr">
             <a:noAutofit/>
           </a:bodyPr>
-          <a:lstStyle xmlns:a="http://schemas.openxmlformats.org/drawingml/2006/main"/>
-          <a:p xmlns:a="http://schemas.openxmlformats.org/drawingml/2006/main">
-            <a:pPr algn="l">
+          <a:lstStyle xmlns:a="http://schemas.openxmlformats.org/drawingml/2006/main">
+            <a:defPPr algn="ctr">
+              <a:defRPr sz="10500" b="1">
+                <a:gradFill>
+                  <a:gsLst>
+                    <a:gs pos="0">
+                      <a:srgbClr val="FFB8E9"/>
+                    </a:gs>
+                    <a:gs pos="100000">
+                      <a:srgbClr val="FF00BC"/>
+                    </a:gs>
+                  </a:gsLst>
+                  <a:lin ang="0"/>
+                </a:gradFill>
+                <a:latin typeface="Bricolage Grotesque"/>
+                <a:ea typeface="Bricolage Grotesque"/>
+                <a:cs typeface="Bricolage Grotesque"/>
+              </a:defRPr>
+            </a:defPPr>
+          </a:lstStyle>
+          <a:p xmlns:a="http://schemas.openxmlformats.org/drawingml/2006/main">
+            <a:pPr algn="ctr">
               <a:buNone/>
-              <a:defRPr sz="5700" b="1">
+              <a:defRPr sz="10500" b="1">
                 <a:solidFill>
-                  <a:srgbClr val="EBEBEB"/>
+                  <a:srgbClr val="FFB8E9"/>
                 </a:solidFill>
                 <a:latin typeface="Bricolage Grotesque"/>
                 <a:ea typeface="Bricolage Grotesque"/>
@@ -6706,7 +6475,7 @@
               </a:defRPr>
             </a:pPr>
             <a:r>
-              <a:rPr sz="5700" b="1">
+              <a:rPr sz="10500" b="1">
                 <a:gradFill>
                   <a:gsLst>
                     <a:gs pos="0">
@@ -6722,1019 +6491,7 @@
                 <a:ea typeface="Bricolage Grotesque"/>
                 <a:cs typeface="Bricolage Grotesque"/>
               </a:rPr>
-              <a:t>Reviews and totals</a:t>
-            </a:r>
-          </a:p>
-        </p:txBody>
-      </p:sp>
-      <p:sp>
-        <p:nvSpPr>
-          <p:cNvPr id="8" name="text-172">
-            <a:extLst xmlns:a="http://schemas.openxmlformats.org/drawingml/2006/main">
-              <a:ext uri="{FF2B5EF4-FFF2-40B4-BE49-F238E27FC236}">
-                <a16:creationId xmlns:a16="http://schemas.microsoft.com/office/drawing/2014/main" id="{6454454F-0012-428E-90F2-399AC2AD2568}"/>
-              </a:ext>
-            </a:extLst>
-          </p:cNvPr>
-          <p:cNvSpPr>
-            <a:spLocks xmlns:a="http://schemas.openxmlformats.org/drawingml/2006/main" noGrp="1"/>
-          </p:cNvSpPr>
-          <p:nvPr/>
-        </p:nvSpPr>
-        <p:spPr>
-          <a:xfrm xmlns:a="http://schemas.openxmlformats.org/drawingml/2006/main">
-            <a:off x="685800" y="9744075"/>
-            <a:ext cx="13811250" cy="304800"/>
-          </a:xfrm>
-          <a:prstGeom xmlns:a="http://schemas.openxmlformats.org/drawingml/2006/main" prst="rect">
-            <a:avLst/>
-          </a:prstGeom>
-          <a:noFill xmlns:a="http://schemas.openxmlformats.org/drawingml/2006/main"/>
-          <a:ln xmlns:a="http://schemas.openxmlformats.org/drawingml/2006/main" w="0">
-            <a:noFill/>
-          </a:ln>
-        </p:spPr>
-        <p:txBody>
-          <a:bodyPr xmlns:a="http://schemas.openxmlformats.org/drawingml/2006/main" wrap="square" lIns="0" tIns="0" rIns="0" bIns="0" anchor="t">
-            <a:noAutofit/>
-          </a:bodyPr>
-          <a:lstStyle xmlns:a="http://schemas.openxmlformats.org/drawingml/2006/main"/>
-          <a:p xmlns:a="http://schemas.openxmlformats.org/drawingml/2006/main">
-            <a:pPr algn="l">
-              <a:buNone/>
-              <a:defRPr sz="1725" b="0">
-                <a:solidFill>
-                  <a:srgbClr val="AAA7AF"/>
-                </a:solidFill>
-                <a:latin typeface="Inter"/>
-                <a:ea typeface="Inter"/>
-                <a:cs typeface="Inter"/>
-              </a:defRPr>
-            </a:pPr>
-            <a:r>
-              <a:rPr sz="1725" b="0">
-                <a:solidFill>
-                  <a:srgbClr val="AAA7AF"/>
-                </a:solidFill>
-                <a:latin typeface="Inter"/>
-                <a:ea typeface="Inter"/>
-                <a:cs typeface="Inter"/>
-              </a:rPr>
-              <a:t>Built and tested. OpenArt integration and real-data validation remain.</a:t>
-            </a:r>
-          </a:p>
-        </p:txBody>
-      </p:sp>
-      <p:sp>
-        <p:nvSpPr>
-          <p:cNvPr id="9" name="text-173">
-            <a:extLst xmlns:a="http://schemas.openxmlformats.org/drawingml/2006/main">
-              <a:ext uri="{FF2B5EF4-FFF2-40B4-BE49-F238E27FC236}">
-                <a16:creationId xmlns:a16="http://schemas.microsoft.com/office/drawing/2014/main" id="{447867C6-1A72-460E-8969-70CD45C7AB41}"/>
-              </a:ext>
-            </a:extLst>
-          </p:cNvPr>
-          <p:cNvSpPr>
-            <a:spLocks xmlns:a="http://schemas.openxmlformats.org/drawingml/2006/main" noGrp="1"/>
-          </p:cNvSpPr>
-          <p:nvPr/>
-        </p:nvSpPr>
-        <p:spPr>
-          <a:xfrm xmlns:a="http://schemas.openxmlformats.org/drawingml/2006/main">
-            <a:off x="13620750" y="9744075"/>
-            <a:ext cx="4000500" cy="304800"/>
-          </a:xfrm>
-          <a:prstGeom xmlns:a="http://schemas.openxmlformats.org/drawingml/2006/main" prst="rect">
-            <a:avLst/>
-          </a:prstGeom>
-          <a:noFill xmlns:a="http://schemas.openxmlformats.org/drawingml/2006/main"/>
-          <a:ln xmlns:a="http://schemas.openxmlformats.org/drawingml/2006/main" w="0">
-            <a:noFill/>
-          </a:ln>
-        </p:spPr>
-        <p:txBody>
-          <a:bodyPr xmlns:a="http://schemas.openxmlformats.org/drawingml/2006/main" wrap="square" lIns="0" tIns="0" rIns="0" bIns="0" anchor="t">
-            <a:noAutofit/>
-          </a:bodyPr>
-          <a:lstStyle xmlns:a="http://schemas.openxmlformats.org/drawingml/2006/main"/>
-          <a:p xmlns:a="http://schemas.openxmlformats.org/drawingml/2006/main">
-            <a:pPr algn="r">
-              <a:buNone/>
-              <a:defRPr sz="1725" b="0">
-                <a:solidFill>
-                  <a:srgbClr val="AAA7AF"/>
-                </a:solidFill>
-                <a:latin typeface="Inter"/>
-                <a:ea typeface="Inter"/>
-                <a:cs typeface="Inter"/>
-              </a:defRPr>
-            </a:pPr>
-            <a:r>
-              <a:rPr sz="1725" b="0">
-                <a:solidFill>
-                  <a:srgbClr val="AAA7AF"/>
-                </a:solidFill>
-                <a:latin typeface="Inter"/>
-                <a:ea typeface="Inter"/>
-                <a:cs typeface="Inter"/>
-              </a:rPr>
-              <a:t>Final code</a:t>
-            </a:r>
-          </a:p>
-        </p:txBody>
-      </p:sp>
-      <p:sp>
-        <p:nvSpPr>
-          <p:cNvPr id="22" name="simple-104">
-            <a:extLst xmlns:a="http://schemas.openxmlformats.org/drawingml/2006/main">
-              <a:ext uri="{FF2B5EF4-FFF2-40B4-BE49-F238E27FC236}">
-                <a16:creationId xmlns:a16="http://schemas.microsoft.com/office/drawing/2014/main" id="{C5302B26-1AE3-4F7F-9D98-AC7969F19A08}"/>
-              </a:ext>
-            </a:extLst>
-          </p:cNvPr>
-          <p:cNvSpPr>
-            <a:spLocks xmlns:a="http://schemas.openxmlformats.org/drawingml/2006/main" noGrp="1"/>
-          </p:cNvSpPr>
-          <p:nvPr/>
-        </p:nvSpPr>
-        <p:spPr>
-          <a:xfrm xmlns:a="http://schemas.openxmlformats.org/drawingml/2006/main">
-            <a:off x="695325" y="2305050"/>
-            <a:ext cx="16192500" cy="514350"/>
-          </a:xfrm>
-          <a:prstGeom xmlns:a="http://schemas.openxmlformats.org/drawingml/2006/main" prst="rect">
-            <a:avLst/>
-          </a:prstGeom>
-          <a:noFill xmlns:a="http://schemas.openxmlformats.org/drawingml/2006/main"/>
-          <a:ln xmlns:a="http://schemas.openxmlformats.org/drawingml/2006/main" w="0">
-            <a:noFill/>
-          </a:ln>
-        </p:spPr>
-        <p:txBody>
-          <a:bodyPr xmlns:a="http://schemas.openxmlformats.org/drawingml/2006/main" wrap="square" lIns="0" tIns="0" rIns="0" bIns="0" anchor="t">
-            <a:noAutofit/>
-          </a:bodyPr>
-          <a:lstStyle xmlns:a="http://schemas.openxmlformats.org/drawingml/2006/main"/>
-          <a:p xmlns:a="http://schemas.openxmlformats.org/drawingml/2006/main">
-            <a:pPr algn="l">
-              <a:buNone/>
-              <a:defRPr sz="2400" b="0">
-                <a:solidFill>
-                  <a:srgbClr val="D2D0D6"/>
-                </a:solidFill>
-                <a:latin typeface="Inter"/>
-                <a:ea typeface="Inter"/>
-                <a:cs typeface="Inter"/>
-              </a:defRPr>
-            </a:pPr>
-            <a:r>
-              <a:rPr sz="2400" b="0">
-                <a:solidFill>
-                  <a:srgbClr val="D2D0D6"/>
-                </a:solidFill>
-                <a:latin typeface="Inter"/>
-                <a:ea typeface="Inter"/>
-                <a:cs typeface="Inter"/>
-              </a:rPr>
-              <a:t>Four independent reviews found roughly 60 issues; fixes have regression coverage</a:t>
-            </a:r>
-          </a:p>
-        </p:txBody>
-      </p:sp>
-      <p:sp>
-        <p:nvSpPr>
-          <p:cNvPr id="23" name="">
-            <a:extLst xmlns:a="http://schemas.openxmlformats.org/drawingml/2006/main">
-              <a:ext uri="{FF2B5EF4-FFF2-40B4-BE49-F238E27FC236}">
-                <a16:creationId xmlns:a16="http://schemas.microsoft.com/office/drawing/2014/main" id="{056A2FF7-3D9A-4488-BFEB-58D52EF16FC0}"/>
-              </a:ext>
-            </a:extLst>
-          </p:cNvPr>
-          <p:cNvSpPr>
-            <a:spLocks xmlns:a="http://schemas.openxmlformats.org/drawingml/2006/main" noGrp="1"/>
-          </p:cNvSpPr>
-          <p:nvPr/>
-        </p:nvSpPr>
-        <p:spPr>
-          <a:xfrm xmlns:a="http://schemas.openxmlformats.org/drawingml/2006/main">
-            <a:off x="666750" y="3362325"/>
-            <a:ext cx="8077200" cy="2333625"/>
-          </a:xfrm>
-          <a:prstGeom xmlns:a="http://schemas.openxmlformats.org/drawingml/2006/main" prst="roundRect">
-            <a:avLst>
-              <a:gd name="adj" fmla="val 12245"/>
-            </a:avLst>
-          </a:prstGeom>
-          <a:gradFill xmlns:a="http://schemas.openxmlformats.org/drawingml/2006/main">
-            <a:gsLst>
-              <a:gs pos="0">
-                <a:srgbClr val="19191C"/>
-              </a:gs>
-              <a:gs pos="100000">
-                <a:srgbClr val="141416"/>
-              </a:gs>
-            </a:gsLst>
-            <a:lin ang="5400000"/>
-          </a:gradFill>
-          <a:ln xmlns:a="http://schemas.openxmlformats.org/drawingml/2006/main" w="14288">
-            <a:gradFill>
-              <a:gsLst>
-                <a:gs pos="0">
-                  <a:srgbClr val="B78AA8"/>
-                </a:gs>
-                <a:gs pos="100000">
-                  <a:srgbClr val="FF00BC"/>
-                </a:gs>
-              </a:gsLst>
-              <a:lin ang="5400000"/>
-            </a:gradFill>
-          </a:ln>
-        </p:spPr>
-      </p:sp>
-      <p:sp>
-        <p:nvSpPr>
-          <p:cNvPr id="24" name="simple-105">
-            <a:extLst xmlns:a="http://schemas.openxmlformats.org/drawingml/2006/main">
-              <a:ext uri="{FF2B5EF4-FFF2-40B4-BE49-F238E27FC236}">
-                <a16:creationId xmlns:a16="http://schemas.microsoft.com/office/drawing/2014/main" id="{FDCB600A-ABD8-489E-89E1-74C6B2CB5974}"/>
-              </a:ext>
-            </a:extLst>
-          </p:cNvPr>
-          <p:cNvSpPr>
-            <a:spLocks xmlns:a="http://schemas.openxmlformats.org/drawingml/2006/main" noGrp="1"/>
-          </p:cNvSpPr>
-          <p:nvPr/>
-        </p:nvSpPr>
-        <p:spPr>
-          <a:xfrm xmlns:a="http://schemas.openxmlformats.org/drawingml/2006/main">
-            <a:off x="1047750" y="3629025"/>
-            <a:ext cx="7239000" cy="1200150"/>
-          </a:xfrm>
-          <a:prstGeom xmlns:a="http://schemas.openxmlformats.org/drawingml/2006/main" prst="rect">
-            <a:avLst/>
-          </a:prstGeom>
-          <a:noFill xmlns:a="http://schemas.openxmlformats.org/drawingml/2006/main"/>
-          <a:ln xmlns:a="http://schemas.openxmlformats.org/drawingml/2006/main" w="0">
-            <a:noFill/>
-          </a:ln>
-        </p:spPr>
-        <p:txBody>
-          <a:bodyPr xmlns:a="http://schemas.openxmlformats.org/drawingml/2006/main" wrap="square" lIns="0" tIns="0" rIns="0" bIns="0" anchor="t">
-            <a:noAutofit/>
-          </a:bodyPr>
-          <a:lstStyle xmlns:a="http://schemas.openxmlformats.org/drawingml/2006/main"/>
-          <a:p xmlns:a="http://schemas.openxmlformats.org/drawingml/2006/main">
-            <a:pPr algn="l">
-              <a:buNone/>
-              <a:defRPr sz="7725" b="1">
-                <a:solidFill>
-                  <a:srgbClr val="FF45CF"/>
-                </a:solidFill>
-                <a:latin typeface="Bricolage Grotesque"/>
-                <a:ea typeface="Bricolage Grotesque"/>
-                <a:cs typeface="Bricolage Grotesque"/>
-              </a:defRPr>
-            </a:pPr>
-            <a:r>
-              <a:rPr sz="7725" b="1">
-                <a:solidFill>
-                  <a:srgbClr val="FF45CF"/>
-                </a:solidFill>
-                <a:latin typeface="Bricolage Grotesque"/>
-                <a:ea typeface="Bricolage Grotesque"/>
-                <a:cs typeface="Bricolage Grotesque"/>
-              </a:rPr>
-              <a:t>1,484</a:t>
-            </a:r>
-          </a:p>
-        </p:txBody>
-      </p:sp>
-      <p:sp>
-        <p:nvSpPr>
-          <p:cNvPr id="25" name="simple-106">
-            <a:extLst xmlns:a="http://schemas.openxmlformats.org/drawingml/2006/main">
-              <a:ext uri="{FF2B5EF4-FFF2-40B4-BE49-F238E27FC236}">
-                <a16:creationId xmlns:a16="http://schemas.microsoft.com/office/drawing/2014/main" id="{6A18108C-FFBE-4BBD-9E88-54B988BD4299}"/>
-              </a:ext>
-            </a:extLst>
-          </p:cNvPr>
-          <p:cNvSpPr>
-            <a:spLocks xmlns:a="http://schemas.openxmlformats.org/drawingml/2006/main" noGrp="1"/>
-          </p:cNvSpPr>
-          <p:nvPr/>
-        </p:nvSpPr>
-        <p:spPr>
-          <a:xfrm xmlns:a="http://schemas.openxmlformats.org/drawingml/2006/main">
-            <a:off x="1047750" y="5019675"/>
-            <a:ext cx="7239000" cy="419100"/>
-          </a:xfrm>
-          <a:prstGeom xmlns:a="http://schemas.openxmlformats.org/drawingml/2006/main" prst="rect">
-            <a:avLst/>
-          </a:prstGeom>
-          <a:noFill xmlns:a="http://schemas.openxmlformats.org/drawingml/2006/main"/>
-          <a:ln xmlns:a="http://schemas.openxmlformats.org/drawingml/2006/main" w="0">
-            <a:noFill/>
-          </a:ln>
-        </p:spPr>
-        <p:txBody>
-          <a:bodyPr xmlns:a="http://schemas.openxmlformats.org/drawingml/2006/main" wrap="square" lIns="0" tIns="0" rIns="0" bIns="0" anchor="t">
-            <a:noAutofit/>
-          </a:bodyPr>
-          <a:lstStyle xmlns:a="http://schemas.openxmlformats.org/drawingml/2006/main"/>
-          <a:p xmlns:a="http://schemas.openxmlformats.org/drawingml/2006/main">
-            <a:pPr algn="l">
-              <a:buNone/>
-              <a:defRPr sz="2475" b="0">
-                <a:solidFill>
-                  <a:srgbClr val="D2D0D6"/>
-                </a:solidFill>
-                <a:latin typeface="Inter"/>
-                <a:ea typeface="Inter"/>
-                <a:cs typeface="Inter"/>
-              </a:defRPr>
-            </a:pPr>
-            <a:r>
-              <a:rPr sz="2475" b="0">
-                <a:solidFill>
-                  <a:srgbClr val="D2D0D6"/>
-                </a:solidFill>
-                <a:latin typeface="Inter"/>
-                <a:ea typeface="Inter"/>
-                <a:cs typeface="Inter"/>
-              </a:rPr>
-              <a:t>reported TypeScript tests</a:t>
-            </a:r>
-          </a:p>
-        </p:txBody>
-      </p:sp>
-      <p:sp>
-        <p:nvSpPr>
-          <p:cNvPr id="26" name="">
-            <a:extLst xmlns:a="http://schemas.openxmlformats.org/drawingml/2006/main">
-              <a:ext uri="{FF2B5EF4-FFF2-40B4-BE49-F238E27FC236}">
-                <a16:creationId xmlns:a16="http://schemas.microsoft.com/office/drawing/2014/main" id="{9E688634-4CB9-4988-A84A-5787D537E8E5}"/>
-              </a:ext>
-            </a:extLst>
-          </p:cNvPr>
-          <p:cNvSpPr>
-            <a:spLocks xmlns:a="http://schemas.openxmlformats.org/drawingml/2006/main" noGrp="1"/>
-          </p:cNvSpPr>
-          <p:nvPr/>
-        </p:nvSpPr>
-        <p:spPr>
-          <a:xfrm xmlns:a="http://schemas.openxmlformats.org/drawingml/2006/main">
-            <a:off x="666750" y="5962650"/>
-            <a:ext cx="8077200" cy="2333625"/>
-          </a:xfrm>
-          <a:prstGeom xmlns:a="http://schemas.openxmlformats.org/drawingml/2006/main" prst="roundRect">
-            <a:avLst>
-              <a:gd name="adj" fmla="val 12245"/>
-            </a:avLst>
-          </a:prstGeom>
-          <a:gradFill xmlns:a="http://schemas.openxmlformats.org/drawingml/2006/main">
-            <a:gsLst>
-              <a:gs pos="0">
-                <a:srgbClr val="19191C"/>
-              </a:gs>
-              <a:gs pos="100000">
-                <a:srgbClr val="141416"/>
-              </a:gs>
-            </a:gsLst>
-            <a:lin ang="5400000"/>
-          </a:gradFill>
-          <a:ln xmlns:a="http://schemas.openxmlformats.org/drawingml/2006/main" w="10478">
-            <a:gradFill>
-              <a:gsLst>
-                <a:gs pos="0">
-                  <a:srgbClr val="5B585F"/>
-                </a:gs>
-                <a:gs pos="100000">
-                  <a:srgbClr val="323137"/>
-                </a:gs>
-              </a:gsLst>
-              <a:lin ang="5400000"/>
-            </a:gradFill>
-          </a:ln>
-        </p:spPr>
-      </p:sp>
-      <p:sp>
-        <p:nvSpPr>
-          <p:cNvPr id="27" name="simple-107">
-            <a:extLst xmlns:a="http://schemas.openxmlformats.org/drawingml/2006/main">
-              <a:ext uri="{FF2B5EF4-FFF2-40B4-BE49-F238E27FC236}">
-                <a16:creationId xmlns:a16="http://schemas.microsoft.com/office/drawing/2014/main" id="{23863C39-DD27-4C8D-B8C8-3BF1AA8F3610}"/>
-              </a:ext>
-            </a:extLst>
-          </p:cNvPr>
-          <p:cNvSpPr>
-            <a:spLocks xmlns:a="http://schemas.openxmlformats.org/drawingml/2006/main" noGrp="1"/>
-          </p:cNvSpPr>
-          <p:nvPr/>
-        </p:nvSpPr>
-        <p:spPr>
-          <a:xfrm xmlns:a="http://schemas.openxmlformats.org/drawingml/2006/main">
-            <a:off x="1047750" y="6229350"/>
-            <a:ext cx="7239000" cy="1200150"/>
-          </a:xfrm>
-          <a:prstGeom xmlns:a="http://schemas.openxmlformats.org/drawingml/2006/main" prst="rect">
-            <a:avLst/>
-          </a:prstGeom>
-          <a:noFill xmlns:a="http://schemas.openxmlformats.org/drawingml/2006/main"/>
-          <a:ln xmlns:a="http://schemas.openxmlformats.org/drawingml/2006/main" w="0">
-            <a:noFill/>
-          </a:ln>
-        </p:spPr>
-        <p:txBody>
-          <a:bodyPr xmlns:a="http://schemas.openxmlformats.org/drawingml/2006/main" wrap="square" lIns="0" tIns="0" rIns="0" bIns="0" anchor="t">
-            <a:noAutofit/>
-          </a:bodyPr>
-          <a:lstStyle xmlns:a="http://schemas.openxmlformats.org/drawingml/2006/main"/>
-          <a:p xmlns:a="http://schemas.openxmlformats.org/drawingml/2006/main">
-            <a:pPr algn="l">
-              <a:buNone/>
-              <a:defRPr sz="7725" b="1">
-                <a:solidFill>
-                  <a:srgbClr val="EBEBEB"/>
-                </a:solidFill>
-                <a:latin typeface="Bricolage Grotesque"/>
-                <a:ea typeface="Bricolage Grotesque"/>
-                <a:cs typeface="Bricolage Grotesque"/>
-              </a:defRPr>
-            </a:pPr>
-            <a:r>
-              <a:rPr sz="7725" b="1">
-                <a:solidFill>
-                  <a:srgbClr val="EBEBEB"/>
-                </a:solidFill>
-                <a:latin typeface="Bricolage Grotesque"/>
-                <a:ea typeface="Bricolage Grotesque"/>
-                <a:cs typeface="Bricolage Grotesque"/>
-              </a:rPr>
-              <a:t>505</a:t>
-            </a:r>
-          </a:p>
-        </p:txBody>
-      </p:sp>
-      <p:sp>
-        <p:nvSpPr>
-          <p:cNvPr id="28" name="simple-108">
-            <a:extLst xmlns:a="http://schemas.openxmlformats.org/drawingml/2006/main">
-              <a:ext uri="{FF2B5EF4-FFF2-40B4-BE49-F238E27FC236}">
-                <a16:creationId xmlns:a16="http://schemas.microsoft.com/office/drawing/2014/main" id="{91B94996-5B12-4888-BE2E-C33B8A7004E7}"/>
-              </a:ext>
-            </a:extLst>
-          </p:cNvPr>
-          <p:cNvSpPr>
-            <a:spLocks xmlns:a="http://schemas.openxmlformats.org/drawingml/2006/main" noGrp="1"/>
-          </p:cNvSpPr>
-          <p:nvPr/>
-        </p:nvSpPr>
-        <p:spPr>
-          <a:xfrm xmlns:a="http://schemas.openxmlformats.org/drawingml/2006/main">
-            <a:off x="1047750" y="7620000"/>
-            <a:ext cx="7239000" cy="419100"/>
-          </a:xfrm>
-          <a:prstGeom xmlns:a="http://schemas.openxmlformats.org/drawingml/2006/main" prst="rect">
-            <a:avLst/>
-          </a:prstGeom>
-          <a:noFill xmlns:a="http://schemas.openxmlformats.org/drawingml/2006/main"/>
-          <a:ln xmlns:a="http://schemas.openxmlformats.org/drawingml/2006/main" w="0">
-            <a:noFill/>
-          </a:ln>
-        </p:spPr>
-        <p:txBody>
-          <a:bodyPr xmlns:a="http://schemas.openxmlformats.org/drawingml/2006/main" wrap="square" lIns="0" tIns="0" rIns="0" bIns="0" anchor="t">
-            <a:noAutofit/>
-          </a:bodyPr>
-          <a:lstStyle xmlns:a="http://schemas.openxmlformats.org/drawingml/2006/main"/>
-          <a:p xmlns:a="http://schemas.openxmlformats.org/drawingml/2006/main">
-            <a:pPr algn="l">
-              <a:buNone/>
-              <a:defRPr sz="2475" b="0">
-                <a:solidFill>
-                  <a:srgbClr val="D2D0D6"/>
-                </a:solidFill>
-                <a:latin typeface="Inter"/>
-                <a:ea typeface="Inter"/>
-                <a:cs typeface="Inter"/>
-              </a:defRPr>
-            </a:pPr>
-            <a:r>
-              <a:rPr sz="2475" b="0">
-                <a:solidFill>
-                  <a:srgbClr val="D2D0D6"/>
-                </a:solidFill>
-                <a:latin typeface="Inter"/>
-                <a:ea typeface="Inter"/>
-                <a:cs typeface="Inter"/>
-              </a:rPr>
-              <a:t>dbt checks</a:t>
-            </a:r>
-          </a:p>
-        </p:txBody>
-      </p:sp>
-      <p:sp>
-        <p:nvSpPr>
-          <p:cNvPr id="29" name="">
-            <a:extLst xmlns:a="http://schemas.openxmlformats.org/drawingml/2006/main">
-              <a:ext uri="{FF2B5EF4-FFF2-40B4-BE49-F238E27FC236}">
-                <a16:creationId xmlns:a16="http://schemas.microsoft.com/office/drawing/2014/main" id="{95580BDF-5881-463F-A0EE-638E129A3EA8}"/>
-              </a:ext>
-            </a:extLst>
-          </p:cNvPr>
-          <p:cNvSpPr>
-            <a:spLocks xmlns:a="http://schemas.openxmlformats.org/drawingml/2006/main" noGrp="1"/>
-          </p:cNvSpPr>
-          <p:nvPr/>
-        </p:nvSpPr>
-        <p:spPr>
-          <a:xfrm xmlns:a="http://schemas.openxmlformats.org/drawingml/2006/main">
-            <a:off x="9010650" y="3362325"/>
-            <a:ext cx="8610600" cy="4933950"/>
-          </a:xfrm>
-          <a:prstGeom xmlns:a="http://schemas.openxmlformats.org/drawingml/2006/main" prst="roundRect">
-            <a:avLst>
-              <a:gd name="adj" fmla="val 5792"/>
-            </a:avLst>
-          </a:prstGeom>
-          <a:gradFill xmlns:a="http://schemas.openxmlformats.org/drawingml/2006/main">
-            <a:gsLst>
-              <a:gs pos="0">
-                <a:srgbClr val="19191C"/>
-              </a:gs>
-              <a:gs pos="100000">
-                <a:srgbClr val="141416"/>
-              </a:gs>
-            </a:gsLst>
-            <a:lin ang="5400000"/>
-          </a:gradFill>
-          <a:ln xmlns:a="http://schemas.openxmlformats.org/drawingml/2006/main" w="10478">
-            <a:gradFill>
-              <a:gsLst>
-                <a:gs pos="0">
-                  <a:srgbClr val="5B585F"/>
-                </a:gs>
-                <a:gs pos="100000">
-                  <a:srgbClr val="323137"/>
-                </a:gs>
-              </a:gsLst>
-              <a:lin ang="5400000"/>
-            </a:gradFill>
-          </a:ln>
-        </p:spPr>
-      </p:sp>
-      <p:sp>
-        <p:nvSpPr>
-          <p:cNvPr id="30" name="simple-109">
-            <a:extLst xmlns:a="http://schemas.openxmlformats.org/drawingml/2006/main">
-              <a:ext uri="{FF2B5EF4-FFF2-40B4-BE49-F238E27FC236}">
-                <a16:creationId xmlns:a16="http://schemas.microsoft.com/office/drawing/2014/main" id="{860473D5-5A79-4ECE-9170-CF0F98067412}"/>
-              </a:ext>
-            </a:extLst>
-          </p:cNvPr>
-          <p:cNvSpPr>
-            <a:spLocks xmlns:a="http://schemas.openxmlformats.org/drawingml/2006/main" noGrp="1"/>
-          </p:cNvSpPr>
-          <p:nvPr/>
-        </p:nvSpPr>
-        <p:spPr>
-          <a:xfrm xmlns:a="http://schemas.openxmlformats.org/drawingml/2006/main">
-            <a:off x="9382125" y="3705225"/>
-            <a:ext cx="7858125" cy="609600"/>
-          </a:xfrm>
-          <a:prstGeom xmlns:a="http://schemas.openxmlformats.org/drawingml/2006/main" prst="rect">
-            <a:avLst/>
-          </a:prstGeom>
-          <a:noFill xmlns:a="http://schemas.openxmlformats.org/drawingml/2006/main"/>
-          <a:ln xmlns:a="http://schemas.openxmlformats.org/drawingml/2006/main" w="0">
-            <a:noFill/>
-          </a:ln>
-        </p:spPr>
-        <p:txBody>
-          <a:bodyPr xmlns:a="http://schemas.openxmlformats.org/drawingml/2006/main" wrap="square" lIns="0" tIns="0" rIns="0" bIns="0" anchor="t">
-            <a:noAutofit/>
-          </a:bodyPr>
-          <a:lstStyle xmlns:a="http://schemas.openxmlformats.org/drawingml/2006/main"/>
-          <a:p xmlns:a="http://schemas.openxmlformats.org/drawingml/2006/main">
-            <a:pPr algn="l">
-              <a:buNone/>
-              <a:defRPr sz="3375" b="1">
-                <a:solidFill>
-                  <a:srgbClr val="EBEBEB"/>
-                </a:solidFill>
-                <a:latin typeface="Bricolage Grotesque"/>
-                <a:ea typeface="Bricolage Grotesque"/>
-                <a:cs typeface="Bricolage Grotesque"/>
-              </a:defRPr>
-            </a:pPr>
-            <a:r>
-              <a:rPr sz="3375" b="1">
-                <a:solidFill>
-                  <a:srgbClr val="EBEBEB"/>
-                </a:solidFill>
-                <a:latin typeface="Bricolage Grotesque"/>
-                <a:ea typeface="Bricolage Grotesque"/>
-                <a:cs typeface="Bricolage Grotesque"/>
-              </a:rPr>
-              <a:t>Major fixes verified</a:t>
-            </a:r>
-          </a:p>
-        </p:txBody>
-      </p:sp>
-      <p:sp>
-        <p:nvSpPr>
-          <p:cNvPr id="31" name="simple-110">
-            <a:extLst xmlns:a="http://schemas.openxmlformats.org/drawingml/2006/main">
-              <a:ext uri="{FF2B5EF4-FFF2-40B4-BE49-F238E27FC236}">
-                <a16:creationId xmlns:a16="http://schemas.microsoft.com/office/drawing/2014/main" id="{34422155-2006-49BC-8095-747E31BEBEA5}"/>
-              </a:ext>
-            </a:extLst>
-          </p:cNvPr>
-          <p:cNvSpPr>
-            <a:spLocks xmlns:a="http://schemas.openxmlformats.org/drawingml/2006/main" noGrp="1"/>
-          </p:cNvSpPr>
-          <p:nvPr/>
-        </p:nvSpPr>
-        <p:spPr>
-          <a:xfrm xmlns:a="http://schemas.openxmlformats.org/drawingml/2006/main">
-            <a:off x="9410700" y="4762500"/>
-            <a:ext cx="7677150" cy="638175"/>
-          </a:xfrm>
-          <a:prstGeom xmlns:a="http://schemas.openxmlformats.org/drawingml/2006/main" prst="rect">
-            <a:avLst/>
-          </a:prstGeom>
-          <a:noFill xmlns:a="http://schemas.openxmlformats.org/drawingml/2006/main"/>
-          <a:ln xmlns:a="http://schemas.openxmlformats.org/drawingml/2006/main" w="0">
-            <a:noFill/>
-          </a:ln>
-        </p:spPr>
-        <p:txBody>
-          <a:bodyPr xmlns:a="http://schemas.openxmlformats.org/drawingml/2006/main" wrap="square" lIns="0" tIns="0" rIns="0" bIns="0" anchor="t">
-            <a:noAutofit/>
-          </a:bodyPr>
-          <a:lstStyle xmlns:a="http://schemas.openxmlformats.org/drawingml/2006/main"/>
-          <a:p xmlns:a="http://schemas.openxmlformats.org/drawingml/2006/main">
-            <a:pPr algn="l">
-              <a:buNone/>
-              <a:defRPr sz="2325" b="0">
-                <a:solidFill>
-                  <a:srgbClr val="D2D0D6"/>
-                </a:solidFill>
-                <a:latin typeface="Inter"/>
-                <a:ea typeface="Inter"/>
-                <a:cs typeface="Inter"/>
-              </a:defRPr>
-            </a:pPr>
-            <a:r>
-              <a:rPr sz="2325" b="0">
-                <a:solidFill>
-                  <a:srgbClr val="D2D0D6"/>
-                </a:solidFill>
-                <a:latin typeface="Inter"/>
-                <a:ea typeface="Inter"/>
-                <a:cs typeface="Inter"/>
-              </a:rPr>
-              <a:t>Firestore reliability + URL validation</a:t>
-            </a:r>
-          </a:p>
-        </p:txBody>
-      </p:sp>
-      <p:sp>
-        <p:nvSpPr>
-          <p:cNvPr id="32" name="simple-111">
-            <a:extLst xmlns:a="http://schemas.openxmlformats.org/drawingml/2006/main">
-              <a:ext uri="{FF2B5EF4-FFF2-40B4-BE49-F238E27FC236}">
-                <a16:creationId xmlns:a16="http://schemas.microsoft.com/office/drawing/2014/main" id="{3EF5E80A-7D96-4805-A368-49E6091446AC}"/>
-              </a:ext>
-            </a:extLst>
-          </p:cNvPr>
-          <p:cNvSpPr>
-            <a:spLocks xmlns:a="http://schemas.openxmlformats.org/drawingml/2006/main" noGrp="1"/>
-          </p:cNvSpPr>
-          <p:nvPr/>
-        </p:nvSpPr>
-        <p:spPr>
-          <a:xfrm xmlns:a="http://schemas.openxmlformats.org/drawingml/2006/main">
-            <a:off x="9410700" y="5505450"/>
-            <a:ext cx="7677150" cy="638175"/>
-          </a:xfrm>
-          <a:prstGeom xmlns:a="http://schemas.openxmlformats.org/drawingml/2006/main" prst="rect">
-            <a:avLst/>
-          </a:prstGeom>
-          <a:noFill xmlns:a="http://schemas.openxmlformats.org/drawingml/2006/main"/>
-          <a:ln xmlns:a="http://schemas.openxmlformats.org/drawingml/2006/main" w="0">
-            <a:noFill/>
-          </a:ln>
-        </p:spPr>
-        <p:txBody>
-          <a:bodyPr xmlns:a="http://schemas.openxmlformats.org/drawingml/2006/main" wrap="square" lIns="0" tIns="0" rIns="0" bIns="0" anchor="t">
-            <a:noAutofit/>
-          </a:bodyPr>
-          <a:lstStyle xmlns:a="http://schemas.openxmlformats.org/drawingml/2006/main"/>
-          <a:p xmlns:a="http://schemas.openxmlformats.org/drawingml/2006/main">
-            <a:pPr algn="l">
-              <a:buNone/>
-              <a:defRPr sz="2325" b="0">
-                <a:solidFill>
-                  <a:srgbClr val="D2D0D6"/>
-                </a:solidFill>
-                <a:latin typeface="Inter"/>
-                <a:ea typeface="Inter"/>
-                <a:cs typeface="Inter"/>
-              </a:defRPr>
-            </a:pPr>
-            <a:r>
-              <a:rPr sz="2325" b="0">
-                <a:solidFill>
-                  <a:srgbClr val="D2D0D6"/>
-                </a:solidFill>
-                <a:latin typeface="Inter"/>
-                <a:ea typeface="Inter"/>
-                <a:cs typeface="Inter"/>
-              </a:rPr>
-              <a:t>Profit scored at the correct moment</a:t>
-            </a:r>
-          </a:p>
-        </p:txBody>
-      </p:sp>
-      <p:sp>
-        <p:nvSpPr>
-          <p:cNvPr id="33" name="simple-112">
-            <a:extLst xmlns:a="http://schemas.openxmlformats.org/drawingml/2006/main">
-              <a:ext uri="{FF2B5EF4-FFF2-40B4-BE49-F238E27FC236}">
-                <a16:creationId xmlns:a16="http://schemas.microsoft.com/office/drawing/2014/main" id="{F4904533-830E-422D-A41A-E4CDFAC555AC}"/>
-              </a:ext>
-            </a:extLst>
-          </p:cNvPr>
-          <p:cNvSpPr>
-            <a:spLocks xmlns:a="http://schemas.openxmlformats.org/drawingml/2006/main" noGrp="1"/>
-          </p:cNvSpPr>
-          <p:nvPr/>
-        </p:nvSpPr>
-        <p:spPr>
-          <a:xfrm xmlns:a="http://schemas.openxmlformats.org/drawingml/2006/main">
-            <a:off x="9410700" y="6248400"/>
-            <a:ext cx="7677150" cy="638175"/>
-          </a:xfrm>
-          <a:prstGeom xmlns:a="http://schemas.openxmlformats.org/drawingml/2006/main" prst="rect">
-            <a:avLst/>
-          </a:prstGeom>
-          <a:noFill xmlns:a="http://schemas.openxmlformats.org/drawingml/2006/main"/>
-          <a:ln xmlns:a="http://schemas.openxmlformats.org/drawingml/2006/main" w="0">
-            <a:noFill/>
-          </a:ln>
-        </p:spPr>
-        <p:txBody>
-          <a:bodyPr xmlns:a="http://schemas.openxmlformats.org/drawingml/2006/main" wrap="square" lIns="0" tIns="0" rIns="0" bIns="0" anchor="t">
-            <a:noAutofit/>
-          </a:bodyPr>
-          <a:lstStyle xmlns:a="http://schemas.openxmlformats.org/drawingml/2006/main"/>
-          <a:p xmlns:a="http://schemas.openxmlformats.org/drawingml/2006/main">
-            <a:pPr algn="l">
-              <a:buNone/>
-              <a:defRPr sz="2325" b="0">
-                <a:solidFill>
-                  <a:srgbClr val="D2D0D6"/>
-                </a:solidFill>
-                <a:latin typeface="Inter"/>
-                <a:ea typeface="Inter"/>
-                <a:cs typeface="Inter"/>
-              </a:defRPr>
-            </a:pPr>
-            <a:r>
-              <a:rPr sz="2325" b="0">
-                <a:solidFill>
-                  <a:srgbClr val="D2D0D6"/>
-                </a:solidFill>
-                <a:latin typeface="Inter"/>
-                <a:ea typeface="Inter"/>
-                <a:cs typeface="Inter"/>
-              </a:rPr>
-              <a:t>Stop-loss with fewer false alarms</a:t>
-            </a:r>
-          </a:p>
-        </p:txBody>
-      </p:sp>
-      <p:sp>
-        <p:nvSpPr>
-          <p:cNvPr id="34" name="simple-113">
-            <a:extLst xmlns:a="http://schemas.openxmlformats.org/drawingml/2006/main">
-              <a:ext uri="{FF2B5EF4-FFF2-40B4-BE49-F238E27FC236}">
-                <a16:creationId xmlns:a16="http://schemas.microsoft.com/office/drawing/2014/main" id="{AA49F6E9-8C12-4836-A736-6BC62B7581DE}"/>
-              </a:ext>
-            </a:extLst>
-          </p:cNvPr>
-          <p:cNvSpPr>
-            <a:spLocks xmlns:a="http://schemas.openxmlformats.org/drawingml/2006/main" noGrp="1"/>
-          </p:cNvSpPr>
-          <p:nvPr/>
-        </p:nvSpPr>
-        <p:spPr>
-          <a:xfrm xmlns:a="http://schemas.openxmlformats.org/drawingml/2006/main">
-            <a:off x="9410700" y="6991350"/>
-            <a:ext cx="7677150" cy="638175"/>
-          </a:xfrm>
-          <a:prstGeom xmlns:a="http://schemas.openxmlformats.org/drawingml/2006/main" prst="rect">
-            <a:avLst/>
-          </a:prstGeom>
-          <a:noFill xmlns:a="http://schemas.openxmlformats.org/drawingml/2006/main"/>
-          <a:ln xmlns:a="http://schemas.openxmlformats.org/drawingml/2006/main" w="0">
-            <a:noFill/>
-          </a:ln>
-        </p:spPr>
-        <p:txBody>
-          <a:bodyPr xmlns:a="http://schemas.openxmlformats.org/drawingml/2006/main" wrap="square" lIns="0" tIns="0" rIns="0" bIns="0" anchor="t">
-            <a:noAutofit/>
-          </a:bodyPr>
-          <a:lstStyle xmlns:a="http://schemas.openxmlformats.org/drawingml/2006/main"/>
-          <a:p xmlns:a="http://schemas.openxmlformats.org/drawingml/2006/main">
-            <a:pPr algn="l">
-              <a:buNone/>
-              <a:defRPr sz="2325" b="0">
-                <a:solidFill>
-                  <a:srgbClr val="D2D0D6"/>
-                </a:solidFill>
-                <a:latin typeface="Inter"/>
-                <a:ea typeface="Inter"/>
-                <a:cs typeface="Inter"/>
-              </a:defRPr>
-            </a:pPr>
-            <a:r>
-              <a:rPr sz="2325" b="0">
-                <a:solidFill>
-                  <a:srgbClr val="D2D0D6"/>
-                </a:solidFill>
-                <a:latin typeface="Inter"/>
-                <a:ea typeface="Inter"/>
-                <a:cs typeface="Inter"/>
-              </a:rPr>
-              <a:t>27 of 29 injected database bugs caught</a:t>
-            </a:r>
-          </a:p>
-        </p:txBody>
-      </p:sp>
-      <p:sp>
-        <p:nvSpPr>
-          <p:cNvPr id="35" name="simple-114">
-            <a:extLst xmlns:a="http://schemas.openxmlformats.org/drawingml/2006/main">
-              <a:ext uri="{FF2B5EF4-FFF2-40B4-BE49-F238E27FC236}">
-                <a16:creationId xmlns:a16="http://schemas.microsoft.com/office/drawing/2014/main" id="{BDC7B86C-BB71-4408-963B-2BB789534A95}"/>
-              </a:ext>
-            </a:extLst>
-          </p:cNvPr>
-          <p:cNvSpPr>
-            <a:spLocks xmlns:a="http://schemas.openxmlformats.org/drawingml/2006/main" noGrp="1"/>
-          </p:cNvSpPr>
-          <p:nvPr/>
-        </p:nvSpPr>
-        <p:spPr>
-          <a:xfrm xmlns:a="http://schemas.openxmlformats.org/drawingml/2006/main">
-            <a:off x="9410700" y="7839075"/>
-            <a:ext cx="7677150" cy="361950"/>
-          </a:xfrm>
-          <a:prstGeom xmlns:a="http://schemas.openxmlformats.org/drawingml/2006/main" prst="rect">
-            <a:avLst/>
-          </a:prstGeom>
-          <a:noFill xmlns:a="http://schemas.openxmlformats.org/drawingml/2006/main"/>
-          <a:ln xmlns:a="http://schemas.openxmlformats.org/drawingml/2006/main" w="0">
-            <a:noFill/>
-          </a:ln>
-        </p:spPr>
-        <p:txBody>
-          <a:bodyPr xmlns:a="http://schemas.openxmlformats.org/drawingml/2006/main" wrap="square" lIns="0" tIns="0" rIns="0" bIns="0" anchor="t">
-            <a:noAutofit/>
-          </a:bodyPr>
-          <a:lstStyle xmlns:a="http://schemas.openxmlformats.org/drawingml/2006/main"/>
-          <a:p xmlns:a="http://schemas.openxmlformats.org/drawingml/2006/main">
-            <a:pPr algn="l">
-              <a:buNone/>
-              <a:defRPr sz="2025" b="1">
-                <a:solidFill>
-                  <a:srgbClr val="FFB8E9"/>
-                </a:solidFill>
-                <a:latin typeface="Inter"/>
-                <a:ea typeface="Inter"/>
-                <a:cs typeface="Inter"/>
-              </a:defRPr>
-            </a:pPr>
-            <a:r>
-              <a:rPr sz="2025" b="1">
-                <a:solidFill>
-                  <a:srgbClr val="FFB8E9"/>
-                </a:solidFill>
-                <a:latin typeface="Inter"/>
-                <a:ea typeface="Inter"/>
-                <a:cs typeface="Inter"/>
-              </a:rPr>
-              <a:t>Sealed tracking proof rerun on final code</a:t>
-            </a:r>
-          </a:p>
-        </p:txBody>
-      </p:sp>
-      <p:sp>
-        <p:nvSpPr>
-          <p:cNvPr id="36" name="">
-            <a:extLst xmlns:a="http://schemas.openxmlformats.org/drawingml/2006/main">
-              <a:ext uri="{FF2B5EF4-FFF2-40B4-BE49-F238E27FC236}">
-                <a16:creationId xmlns:a16="http://schemas.microsoft.com/office/drawing/2014/main" id="{49AE4213-366F-45C4-9E97-D954D7EFFEFB}"/>
-              </a:ext>
-            </a:extLst>
-          </p:cNvPr>
-          <p:cNvSpPr>
-            <a:spLocks xmlns:a="http://schemas.openxmlformats.org/drawingml/2006/main" noGrp="1"/>
-          </p:cNvSpPr>
-          <p:nvPr/>
-        </p:nvSpPr>
-        <p:spPr>
-          <a:xfrm xmlns:a="http://schemas.openxmlformats.org/drawingml/2006/main">
-            <a:off x="666750" y="8620125"/>
-            <a:ext cx="16954500" cy="885825"/>
-          </a:xfrm>
-          <a:prstGeom xmlns:a="http://schemas.openxmlformats.org/drawingml/2006/main" prst="roundRect">
-            <a:avLst>
-              <a:gd name="adj" fmla="val 32258"/>
-            </a:avLst>
-          </a:prstGeom>
-          <a:gradFill xmlns:a="http://schemas.openxmlformats.org/drawingml/2006/main">
-            <a:gsLst>
-              <a:gs pos="0">
-                <a:srgbClr val="19191C"/>
-              </a:gs>
-              <a:gs pos="100000">
-                <a:srgbClr val="141416"/>
-              </a:gs>
-            </a:gsLst>
-            <a:lin ang="5400000"/>
-          </a:gradFill>
-          <a:ln xmlns:a="http://schemas.openxmlformats.org/drawingml/2006/main" w="10478">
-            <a:gradFill>
-              <a:gsLst>
-                <a:gs pos="0">
-                  <a:srgbClr val="5B585F"/>
-                </a:gs>
-                <a:gs pos="100000">
-                  <a:srgbClr val="323137"/>
-                </a:gs>
-              </a:gsLst>
-              <a:lin ang="5400000"/>
-            </a:gradFill>
-          </a:ln>
-        </p:spPr>
-      </p:sp>
-      <p:sp>
-        <p:nvSpPr>
-          <p:cNvPr id="37" name="simple-115">
-            <a:extLst xmlns:a="http://schemas.openxmlformats.org/drawingml/2006/main">
-              <a:ext uri="{FF2B5EF4-FFF2-40B4-BE49-F238E27FC236}">
-                <a16:creationId xmlns:a16="http://schemas.microsoft.com/office/drawing/2014/main" id="{4B0886CF-282A-4926-80F1-582662B8C078}"/>
-              </a:ext>
-            </a:extLst>
-          </p:cNvPr>
-          <p:cNvSpPr>
-            <a:spLocks xmlns:a="http://schemas.openxmlformats.org/drawingml/2006/main" noGrp="1"/>
-          </p:cNvSpPr>
-          <p:nvPr/>
-        </p:nvSpPr>
-        <p:spPr>
-          <a:xfrm xmlns:a="http://schemas.openxmlformats.org/drawingml/2006/main">
-            <a:off x="1047750" y="8858250"/>
-            <a:ext cx="15859125" cy="495300"/>
-          </a:xfrm>
-          <a:prstGeom xmlns:a="http://schemas.openxmlformats.org/drawingml/2006/main" prst="rect">
-            <a:avLst/>
-          </a:prstGeom>
-          <a:noFill xmlns:a="http://schemas.openxmlformats.org/drawingml/2006/main"/>
-          <a:ln xmlns:a="http://schemas.openxmlformats.org/drawingml/2006/main" w="0">
-            <a:noFill/>
-          </a:ln>
-        </p:spPr>
-        <p:txBody>
-          <a:bodyPr xmlns:a="http://schemas.openxmlformats.org/drawingml/2006/main" wrap="square" lIns="0" tIns="0" rIns="0" bIns="0" anchor="t">
-            <a:noAutofit/>
-          </a:bodyPr>
-          <a:lstStyle xmlns:a="http://schemas.openxmlformats.org/drawingml/2006/main"/>
-          <a:p xmlns:a="http://schemas.openxmlformats.org/drawingml/2006/main">
-            <a:pPr algn="l">
-              <a:buNone/>
-              <a:defRPr sz="2700" b="0">
-                <a:solidFill>
-                  <a:srgbClr val="D2D0D6"/>
-                </a:solidFill>
-                <a:latin typeface="Inter"/>
-                <a:ea typeface="Inter"/>
-                <a:cs typeface="Inter"/>
-              </a:defRPr>
-            </a:pPr>
-            <a:r>
-              <a:rPr sz="2700" b="0">
-                <a:solidFill>
-                  <a:srgbClr val="D2D0D6"/>
-                </a:solidFill>
-                <a:latin typeface="Inter"/>
-                <a:ea typeface="Inter"/>
-                <a:cs typeface="Inter"/>
-              </a:rPr>
-              <a:t>8 packages built. Deployment and real-data validation remain.</a:t>
+              <a:t>Thank you</a:t>
             </a:r>
           </a:p>
         </p:txBody>

</xml_diff>